<commit_message>
Sunum: platform ve indirme bilgileri guncellendi (Windows + macOS, v1.0.0)
Kurulum slaytina Windows 10/11 (x64) + macOS (Apple Silicon) platform
satiri, GitHub Releases (v1.0.0) indirme baglantisi ve macOS paketinin
notarize edilmedigine dair tek cumlelik dipnot eklendi. Tum sunum
ciktilari (TR/EN, html/pptx/pdf) yeniden uretildi.

Co-Authored-By: Claude Fable 5 <noreply@anthropic.com>
</commit_message>
<xml_diff>
--- a/docs/presentation/Akilli_Restaurant_Tanitim_Baski_PUBLIC.pptx
+++ b/docs/presentation/Akilli_Restaurant_Tanitim_Baski_PUBLIC.pptx
@@ -8279,7 +8279,57 @@
                 </a:solidFill>
                 <a:latin typeface="Segoe UI"/>
               </a:rPr>
-              <a:t>Tek dosyalık Windows uygulaması (~57 MB) — Python kurulumu gerekmez</a:t>
+              <a:t>Tek dosyalık uygulama (~57 MB) — Python kurulumu gerekmez</a:t>
+            </a:r>
+          </a:p>
+          <a:p>
+            <a:pPr>
+              <a:spcAft>
+                <a:spcPts val="1000"/>
+              </a:spcAft>
+            </a:pPr>
+            <a:r>
+              <a:rPr sz="1500" b="1">
+                <a:solidFill>
+                  <a:srgbClr val="14508C"/>
+                </a:solidFill>
+                <a:latin typeface="Segoe UI"/>
+              </a:rPr>
+              <a:t>▪  </a:t>
+            </a:r>
+            <a:r>
+              <a:rPr sz="1500" b="0">
+                <a:solidFill>
+                  <a:srgbClr val="26303F"/>
+                </a:solidFill>
+                <a:latin typeface="Segoe UI"/>
+              </a:rPr>
+              <a:t>Windows 10/11 (x64) + macOS (Apple Silicon) — İndirme: github.com/Azizsekerdil/smart-restaurant-management-system/releases (v1.0.0)</a:t>
+            </a:r>
+          </a:p>
+          <a:p>
+            <a:pPr>
+              <a:spcAft>
+                <a:spcPts val="1000"/>
+              </a:spcAft>
+            </a:pPr>
+            <a:r>
+              <a:rPr sz="1500" b="1">
+                <a:solidFill>
+                  <a:srgbClr val="14508C"/>
+                </a:solidFill>
+                <a:latin typeface="Segoe UI"/>
+              </a:rPr>
+              <a:t>▪  </a:t>
+            </a:r>
+            <a:r>
+              <a:rPr sz="1500" b="0">
+                <a:solidFill>
+                  <a:srgbClr val="26303F"/>
+                </a:solidFill>
+                <a:latin typeface="Segoe UI"/>
+              </a:rPr>
+              <a:t>macOS paketi Apple Silicon (arm64) içindir ve notarize edilmemiştir (ilk açılış: sağ tık -&gt; Aç)</a:t>
             </a:r>
           </a:p>
           <a:p>
@@ -8784,7 +8834,7 @@
                 </a:solidFill>
                 <a:latin typeface="Segoe UI"/>
               </a:rPr>
-              <a:t>484 otomatik test; her sürümde linter, biçimlendirici ve güvenlik taraması</a:t>
+              <a:t>486 otomatik test; her sürümde linter, biçimlendirici ve güvenlik taraması</a:t>
             </a:r>
           </a:p>
           <a:p>
@@ -9416,7 +9466,7 @@
                 </a:solidFill>
                 <a:latin typeface="Segoe UI"/>
               </a:rPr>
-              <a:t>484</a:t>
+              <a:t>486</a:t>
             </a:r>
           </a:p>
           <a:p>
@@ -10525,7 +10575,7 @@
                 </a:solidFill>
                 <a:latin typeface="Segoe UI"/>
               </a:rPr>
-              <a:t>484</a:t>
+              <a:t>486</a:t>
             </a:r>
           </a:p>
           <a:p>

</xml_diff>